<commit_message>
move coupon exercise from in-class workshop to homework slide (16 slides)
</commit_message>
<xml_diff>
--- a/slides/fp-in-go-workshop.pptx
+++ b/slides/fp-in-go-workshop.pptx
@@ -21,7 +21,6 @@
     <p:sldId id="269" r:id="rId21"/>
     <p:sldId id="270" r:id="rId22"/>
     <p:sldId id="271" r:id="rId23"/>
-    <p:sldId id="272" r:id="rId24"/>
   </p:sldIdLst>
   <p:sldSz cx="12191695" cy="6858000" type="screen4x3"/>
   <p:notesSz cx="6858000" cy="9144000"/>
@@ -728,7 +727,7 @@
           <a:lstStyle/>
           <a:p>
             <a:r>
-              <a:t>[1:10] ถ้าเวลาเหลือน้อยกว่า 15 นาที ณ จุดนี้ ตัดหน้านี้ทั้งหน้าได้ (พูดประโยคเดียว: 'middleware คือการเอาฟังก์ชันมาคู่กัน ลำดับมีความหมาย') แล้วกระโดดไป workshop — ไม่กระทบเรื่องเล่า</a:t>
+              <a:t>[1:10] ถ้าเวลาเหลือน้อย ตัดหน้านี้ทั้งหน้าได้ (พูดประโยคเดียว: 'middleware คือการเอาฟังก์ชันมาคู่กัน ลำดับมีความหมาย') แล้วกระโดดไปของหวาน — ไม่กระทบเรื่องเล่า</a:t>
             </a:r>
           </a:p>
         </p:txBody>
@@ -798,7 +797,7 @@
           <a:lstStyle/>
           <a:p>
             <a:r>
-              <a:t>[1:25] เดินดูรอบห้อง จุดพลาดบ่อย: (1) ลืมรักษาลำดับคูปองเดิม (2) return slice ใหม่แต่ mutate element ข้างใน — ถามกลับว่า pure จริงไหม (3) แอบเอาการหา coupon ใส่ action อีกที ผู้เรียนเปิด EXERCISE.md ตามได้</a:t>
+              <a:t>[1:25] โชว์อย่างเดียว ไม่ลงลึก: yield คืน false = ผู้อ่านสั่งหยุด ทำให้ infinite sequence ปลอดภัย แถมขำ: int ยัง overflow ถ้าดันอ่านไกล — ของจริงไม่มีอะไร infinite หน้านี้ตัดได้ถ้าเวลาโดนตัด แต่เป็นของที่คนจำได้นาน พยายามรักษาไว้</a:t>
             </a:r>
           </a:p>
         </p:txBody>
@@ -868,7 +867,7 @@
           <a:lstStyle/>
           <a:p>
             <a:r>
-              <a:t>[1:43] เฉลยสั้น ๆ จุดเน้น: action บาง = แค่ 'จุดที่โลกเปลี่ยน' ไม่มีความรู้ธุรกิจเลย ใน solution ตั้งใจไม่เขียนเทสต์ให้ action เพื่อโชว์ขอบเขต</a:t>
+              <a:t>[1:40] ปิดเนื้อหาด้วยกรอบเดียว: 3 คำถามนี้คือสิ่งที่อยากให้จำกลับบ้าน — การบ้านคือโอกาสฝึกใช้มันหน้าเดียว</a:t>
             </a:r>
           </a:p>
         </p:txBody>
@@ -938,7 +937,7 @@
           <a:lstStyle/>
           <a:p>
             <a:r>
-              <a:t>[1:45] โชว์อย่างเดียว ไม่ลงลึก: yield คืน false = ผู้อ่านสั่งหยุด ทำให้ infinite sequence ปลอดภัย แถมขำ: int ยัง overflow ถ้าดันอ่านไกล — ของจริงไม่มีอะไร infinite หน้านี้ตัดได้ถ้าเวลาโดนตัด แต่เป็นของที่คนจำได้นาน พยายามรักษาไว้</a:t>
+              <a:t>[1:48] มอบการบ้าน: ใช้เวลา ~20 นาที ใบ้จุดพลาดบ่อยไว้ด้วย — (1) ลืมรักษาลำดับคูปองเดิม (2) return slice ใหม่แต่ mutate element ข้างใน (ยังไม่ pure) (3) แอบเอาการหา coupon กลับเข้าไปใน action ครั้งหน้าเปิดเฉลยพร้อมกัน</a:t>
             </a:r>
           </a:p>
         </p:txBody>
@@ -1008,76 +1007,6 @@
           <a:lstStyle/>
           <a:p>
             <a:r>
-              <a:t>[1:52] ปิดด้วย call to action: สัปดาห์หน้าหยิบ handler ใน service ตัวเองมา 1 ตัว แยก ACD แล้วดึง calculation ออกมา 1 ชิ้น — 15 นาทีก็คุ้ม</a:t>
-            </a:r>
-          </a:p>
-        </p:txBody>
-      </p:sp>
-      <p:sp>
-        <p:nvSpPr>
-          <p:cNvPr id="4" name="Slide Number Placeholder 3"/>
-          <p:cNvSpPr>
-            <a:spLocks noGrp="1"/>
-          </p:cNvSpPr>
-          <p:nvPr>
-            <p:ph type="sldNum" idx="5" sz="quarter"/>
-          </p:nvPr>
-        </p:nvSpPr>
-        <p:spPr/>
-      </p:sp>
-    </p:spTree>
-  </p:cSld>
-  <p:clrMapOvr>
-    <a:masterClrMapping/>
-  </p:clrMapOvr>
-</p:notes>
-</file>
-
-<file path=ppt/notesSlides/notesSlide17.xml><?xml version="1.0" encoding="utf-8"?>
-<p:notes xmlns:a="http://schemas.openxmlformats.org/drawingml/2006/main" xmlns:p="http://schemas.openxmlformats.org/presentationml/2006/main" xmlns:r="http://schemas.openxmlformats.org/officeDocument/2006/relationships">
-  <p:cSld>
-    <p:spTree>
-      <p:nvGrpSpPr>
-        <p:cNvPr id="1" name=""/>
-        <p:cNvGrpSpPr/>
-        <p:nvPr/>
-      </p:nvGrpSpPr>
-      <p:grpSpPr>
-        <a:xfrm>
-          <a:off x="0" y="0"/>
-          <a:ext cx="0" cy="0"/>
-          <a:chOff x="0" y="0"/>
-          <a:chExt cx="0" cy="0"/>
-        </a:xfrm>
-      </p:grpSpPr>
-      <p:sp>
-        <p:nvSpPr>
-          <p:cNvPr id="2" name="Slide Image Placeholder 1"/>
-          <p:cNvSpPr>
-            <a:spLocks noGrp="1"/>
-          </p:cNvSpPr>
-          <p:nvPr>
-            <p:ph type="sldImg" idx="2"/>
-          </p:nvPr>
-        </p:nvSpPr>
-        <p:spPr/>
-      </p:sp>
-      <p:sp>
-        <p:nvSpPr>
-          <p:cNvPr id="3" name="Notes Placeholder 2"/>
-          <p:cNvSpPr>
-            <a:spLocks noGrp="1"/>
-          </p:cNvSpPr>
-          <p:nvPr>
-            <p:ph type="body" idx="3" sz="quarter"/>
-          </p:nvPr>
-        </p:nvSpPr>
-        <p:spPr/>
-        <p:txBody>
-          <a:bodyPr/>
-          <a:lstStyle/>
-          <a:p>
-            <a:r>
               <a:t>เผื่อ Q&amp;A: (1) ทำไม Go ไม่มี pipe operator → verbose by design + (value, error) ทำ chain ยาก (2) copy-on-write แพงไหม → benchmark ใน go-fp/08: struct เล็กต่างกัน ~0.05 ns/op (3) goroutine/channel เข้ากรอบไหน → channel คือ data, การส่ง/รับคือ action (4) ใครถาม monad → วันนี้ไม่จำเป็น แนะนำหนังสือต่อ</a:t>
             </a:r>
           </a:p>
@@ -1148,7 +1077,7 @@
           <a:lstStyle/>
           <a:p>
             <a:r>
-              <a:t>[0:02] ย้ำสัญญา: ออกจากห้องไปด้วยทักษะ ไม่ใช่ความรู้ลอย ๆ — เล่า flow วันนี้สั้น ๆ: ครึ่งแรกดูโค้ด ครึ่งหลังลงมือทำ (เวลาเริ่มเบี้ยว: middleware เป็นตัวตัดก่อน)</a:t>
+              <a:t>[0:02] ย้ำสัญญา: ออกจากห้องไปด้วยทักษะ ไม่ใช่ความรู้ลอย ๆ — เล่า flow วันนี้สั้น ๆ: ดูโค้ด เขียนโค้ด แล้วมีการบ้านไปต่อที่บ้าน (เวลาเริ่มเบี้ยว: middleware เป็นตัวตัดก่อน)</a:t>
             </a:r>
           </a:p>
         </p:txBody>
@@ -6359,1255 +6288,6 @@
                 </a:solidFill>
                 <a:latin typeface="Noto Sans Thai Looped"/>
               </a:rPr>
-              <a:t>Workshop: แยกคูปองออกจากการส่งอีเมล</a:t>
-            </a:r>
-          </a:p>
-          <a:p>
-            <a:pPr algn="l">
-              <a:spcAft>
-                <a:spcPts val="600"/>
-              </a:spcAft>
-            </a:pPr>
-            <a:r>
-              <a:rPr sz="1500" b="0" i="0">
-                <a:solidFill>
-                  <a:srgbClr val="64748B"/>
-                </a:solidFill>
-                <a:latin typeface="Noto Sans Thai Looped"/>
-              </a:rPr>
-              <a:t>โจทย์จาก Grokking Simplicity บท </a:t>
-            </a:r>
-            <a:r>
-              <a:rPr sz="1500" b="0" i="0">
-                <a:solidFill>
-                  <a:srgbClr val="64748B"/>
-                </a:solidFill>
-                <a:latin typeface="Ubuntu"/>
-              </a:rPr>
-              <a:t>3–5</a:t>
-            </a:r>
-            <a:r>
-              <a:rPr sz="1500" b="0" i="0">
-                <a:solidFill>
-                  <a:srgbClr val="64748B"/>
-                </a:solidFill>
-                <a:latin typeface="Noto Sans Thai Looped"/>
-              </a:rPr>
-              <a:t> พอร์ตเป็น Go — repo: go-fp/</a:t>
-            </a:r>
-            <a:r>
-              <a:rPr sz="1500" b="0" i="0">
-                <a:solidFill>
-                  <a:srgbClr val="64748B"/>
-                </a:solidFill>
-                <a:latin typeface="Ubuntu"/>
-              </a:rPr>
-              <a:t>07-</a:t>
-            </a:r>
-            <a:r>
-              <a:rPr sz="1500" b="0" i="0">
-                <a:solidFill>
-                  <a:srgbClr val="64748B"/>
-                </a:solidFill>
-                <a:latin typeface="Noto Sans Thai Looped"/>
-              </a:rPr>
-              <a:t>coupon-email-exercise</a:t>
-            </a:r>
-          </a:p>
-        </p:txBody>
-      </p:sp>
-      <p:sp>
-        <p:nvSpPr>
-          <p:cNvPr id="3" name="Rectangle 2"/>
-          <p:cNvSpPr/>
-          <p:nvPr/>
-        </p:nvSpPr>
-        <p:spPr>
-          <a:xfrm>
-            <a:off x="502920" y="1207008"/>
-            <a:ext cx="11201400" cy="27940"/>
-          </a:xfrm>
-          <a:prstGeom prst="rect">
-            <a:avLst/>
-          </a:prstGeom>
-          <a:solidFill>
-            <a:srgbClr val="0D9488"/>
-          </a:solidFill>
-          <a:ln>
-            <a:noFill/>
-          </a:ln>
-        </p:spPr>
-        <p:style>
-          <a:lnRef idx="1">
-            <a:schemeClr val="accent1"/>
-          </a:lnRef>
-          <a:fillRef idx="3">
-            <a:schemeClr val="accent1"/>
-          </a:fillRef>
-          <a:effectRef idx="2">
-            <a:schemeClr val="accent1"/>
-          </a:effectRef>
-          <a:fontRef idx="minor">
-            <a:schemeClr val="lt1"/>
-          </a:fontRef>
-        </p:style>
-        <p:txBody>
-          <a:bodyPr rtlCol="0" anchor="ctr"/>
-          <a:lstStyle/>
-          <a:p>
-            <a:pPr algn="ctr"/>
-          </a:p>
-        </p:txBody>
-      </p:sp>
-      <p:sp>
-        <p:nvSpPr>
-          <p:cNvPr id="4" name="Rounded Rectangle 3"/>
-          <p:cNvSpPr/>
-          <p:nvPr/>
-        </p:nvSpPr>
-        <p:spPr>
-          <a:xfrm>
-            <a:off x="548640" y="1874519"/>
-            <a:ext cx="6035040" cy="4114800"/>
-          </a:xfrm>
-          <a:prstGeom prst="roundRect">
-            <a:avLst/>
-          </a:prstGeom>
-          <a:solidFill>
-            <a:srgbClr val="1E1E2E"/>
-          </a:solidFill>
-          <a:ln>
-            <a:noFill/>
-          </a:ln>
-          <a:effectLst/>
-        </p:spPr>
-        <p:style>
-          <a:lnRef idx="1">
-            <a:schemeClr val="accent1"/>
-          </a:lnRef>
-          <a:fillRef idx="3">
-            <a:schemeClr val="accent1"/>
-          </a:fillRef>
-          <a:effectRef idx="2">
-            <a:schemeClr val="accent1"/>
-          </a:effectRef>
-          <a:fontRef idx="minor">
-            <a:schemeClr val="lt1"/>
-          </a:fontRef>
-        </p:style>
-        <p:txBody>
-          <a:bodyPr rtlCol="0" anchor="t" wrap="none" lIns="164592" rIns="109728" tIns="109728"/>
-          <a:lstStyle/>
-          <a:p>
-            <a:pPr algn="l">
-              <a:spcAft>
-                <a:spcPts val="0"/>
-              </a:spcAft>
-            </a:pPr>
-            <a:r>
-              <a:rPr sz="1200" i="1">
-                <a:solidFill>
-                  <a:srgbClr val="94A3B8"/>
-                </a:solidFill>
-                <a:latin typeface="DejaVu Sans Mono"/>
-              </a:rPr>
-              <a:t>// ทุกอย่างอยู่ในฟังก์ชันเดียว — มองแล้วเจออะไรบ้าง?</a:t>
-            </a:r>
-          </a:p>
-          <a:p>
-            <a:pPr algn="l">
-              <a:spcAft>
-                <a:spcPts val="0"/>
-              </a:spcAft>
-            </a:pPr>
-            <a:r>
-              <a:rPr sz="1200" i="0">
-                <a:solidFill>
-                  <a:srgbClr val="E2E8F0"/>
-                </a:solidFill>
-                <a:latin typeface="DejaVu Sans Mono"/>
-              </a:rPr>
-              <a:t>func EmailCoupons(cart Cart, coupons []Coupon,</a:t>
-            </a:r>
-          </a:p>
-          <a:p>
-            <a:pPr algn="l">
-              <a:spcAft>
-                <a:spcPts val="0"/>
-              </a:spcAft>
-            </a:pPr>
-            <a:r>
-              <a:rPr sz="1200" i="0">
-                <a:solidFill>
-                  <a:srgbClr val="E2E8F0"/>
-                </a:solidFill>
-                <a:latin typeface="DejaVu Sans Mono"/>
-              </a:rPr>
-              <a:t>    out io.Writer) error {</a:t>
-            </a:r>
-          </a:p>
-          <a:p>
-            <a:pPr algn="l">
-              <a:spcAft>
-                <a:spcPts val="0"/>
-              </a:spcAft>
-            </a:pPr>
-            <a:r>
-              <a:rPr sz="1200" i="0">
-                <a:solidFill>
-                  <a:srgbClr val="E2E8F0"/>
-                </a:solidFill>
-                <a:latin typeface="DejaVu Sans Mono"/>
-              </a:rPr>
-              <a:t>    fmt.Printf("finding coupons for %s\n", cart.Email)</a:t>
-            </a:r>
-          </a:p>
-          <a:p>
-            <a:pPr algn="l">
-              <a:spcAft>
-                <a:spcPts val="0"/>
-              </a:spcAft>
-            </a:pPr>
-            <a:r>
-              <a:rPr sz="1200" i="0">
-                <a:solidFill>
-                  <a:srgbClr val="E2E8F0"/>
-                </a:solidFill>
-                <a:latin typeface="DejaVu Sans Mono"/>
-              </a:rPr>
-              <a:t>    var codes []string</a:t>
-            </a:r>
-          </a:p>
-          <a:p>
-            <a:pPr algn="l">
-              <a:spcAft>
-                <a:spcPts val="0"/>
-              </a:spcAft>
-            </a:pPr>
-            <a:r>
-              <a:rPr sz="1200" i="0">
-                <a:solidFill>
-                  <a:srgbClr val="E2E8F0"/>
-                </a:solidFill>
-                <a:latin typeface="DejaVu Sans Mono"/>
-              </a:rPr>
-              <a:t>    for _, c := range coupons {</a:t>
-            </a:r>
-          </a:p>
-          <a:p>
-            <a:pPr algn="l">
-              <a:spcAft>
-                <a:spcPts val="0"/>
-              </a:spcAft>
-            </a:pPr>
-            <a:r>
-              <a:rPr sz="1200" i="0">
-                <a:solidFill>
-                  <a:srgbClr val="E2E8F0"/>
-                </a:solidFill>
-                <a:latin typeface="DejaVu Sans Mono"/>
-              </a:rPr>
-              <a:t>        if cart.Total &gt;= c.MinimumTotal &amp;&amp;</a:t>
-            </a:r>
-          </a:p>
-          <a:p>
-            <a:pPr algn="l">
-              <a:spcAft>
-                <a:spcPts val="0"/>
-              </a:spcAft>
-            </a:pPr>
-            <a:r>
-              <a:rPr sz="1200" i="0">
-                <a:solidFill>
-                  <a:srgbClr val="E2E8F0"/>
-                </a:solidFill>
-                <a:latin typeface="DejaVu Sans Mono"/>
-              </a:rPr>
-              <a:t>            (c.Category == "" || c.Category == cart.Category) {</a:t>
-            </a:r>
-          </a:p>
-          <a:p>
-            <a:pPr algn="l">
-              <a:spcAft>
-                <a:spcPts val="0"/>
-              </a:spcAft>
-            </a:pPr>
-            <a:r>
-              <a:rPr sz="1200" i="0">
-                <a:solidFill>
-                  <a:srgbClr val="E2E8F0"/>
-                </a:solidFill>
-                <a:latin typeface="DejaVu Sans Mono"/>
-              </a:rPr>
-              <a:t>            codes = append(codes, c.Code)</a:t>
-            </a:r>
-          </a:p>
-          <a:p>
-            <a:pPr algn="l">
-              <a:spcAft>
-                <a:spcPts val="0"/>
-              </a:spcAft>
-            </a:pPr>
-            <a:r>
-              <a:rPr sz="1200" i="0">
-                <a:solidFill>
-                  <a:srgbClr val="E2E8F0"/>
-                </a:solidFill>
-                <a:latin typeface="DejaVu Sans Mono"/>
-              </a:rPr>
-              <a:t>        }</a:t>
-            </a:r>
-          </a:p>
-          <a:p>
-            <a:pPr algn="l">
-              <a:spcAft>
-                <a:spcPts val="0"/>
-              </a:spcAft>
-            </a:pPr>
-            <a:r>
-              <a:rPr sz="1200" i="0">
-                <a:solidFill>
-                  <a:srgbClr val="E2E8F0"/>
-                </a:solidFill>
-                <a:latin typeface="DejaVu Sans Mono"/>
-              </a:rPr>
-              <a:t>    }</a:t>
-            </a:r>
-          </a:p>
-          <a:p>
-            <a:pPr algn="l">
-              <a:spcAft>
-                <a:spcPts val="0"/>
-              </a:spcAft>
-            </a:pPr>
-            <a:r>
-              <a:rPr sz="1200" i="0">
-                <a:solidFill>
-                  <a:srgbClr val="E2E8F0"/>
-                </a:solidFill>
-                <a:latin typeface="DejaVu Sans Mono"/>
-              </a:rPr>
-              <a:t>    _, err := fmt.Fprintf(out,</a:t>
-            </a:r>
-          </a:p>
-          <a:p>
-            <a:pPr algn="l">
-              <a:spcAft>
-                <a:spcPts val="0"/>
-              </a:spcAft>
-            </a:pPr>
-            <a:r>
-              <a:rPr sz="1200" i="0">
-                <a:solidFill>
-                  <a:srgbClr val="E2E8F0"/>
-                </a:solidFill>
-                <a:latin typeface="DejaVu Sans Mono"/>
-              </a:rPr>
-              <a:t>        "To: %s\nCoupons: %v\n", cart.Email, codes)</a:t>
-            </a:r>
-          </a:p>
-          <a:p>
-            <a:pPr algn="l">
-              <a:spcAft>
-                <a:spcPts val="0"/>
-              </a:spcAft>
-            </a:pPr>
-            <a:r>
-              <a:rPr sz="1200" i="0">
-                <a:solidFill>
-                  <a:srgbClr val="E2E8F0"/>
-                </a:solidFill>
-                <a:latin typeface="DejaVu Sans Mono"/>
-              </a:rPr>
-              <a:t>    return err</a:t>
-            </a:r>
-          </a:p>
-          <a:p>
-            <a:pPr algn="l">
-              <a:spcAft>
-                <a:spcPts val="0"/>
-              </a:spcAft>
-            </a:pPr>
-            <a:r>
-              <a:rPr sz="1200" i="0">
-                <a:solidFill>
-                  <a:srgbClr val="E2E8F0"/>
-                </a:solidFill>
-                <a:latin typeface="DejaVu Sans Mono"/>
-              </a:rPr>
-              <a:t>}</a:t>
-            </a:r>
-          </a:p>
-        </p:txBody>
-      </p:sp>
-      <p:sp>
-        <p:nvSpPr>
-          <p:cNvPr id="5" name="Rounded Rectangle 4"/>
-          <p:cNvSpPr/>
-          <p:nvPr/>
-        </p:nvSpPr>
-        <p:spPr>
-          <a:xfrm>
-            <a:off x="548640" y="1563623"/>
-            <a:ext cx="2176272" cy="274320"/>
-          </a:xfrm>
-          <a:prstGeom prst="roundRect">
-            <a:avLst/>
-          </a:prstGeom>
-          <a:solidFill>
-            <a:srgbClr val="DC2626"/>
-          </a:solidFill>
-          <a:ln>
-            <a:noFill/>
-          </a:ln>
-          <a:effectLst/>
-        </p:spPr>
-        <p:style>
-          <a:lnRef idx="1">
-            <a:schemeClr val="accent1"/>
-          </a:lnRef>
-          <a:fillRef idx="3">
-            <a:schemeClr val="accent1"/>
-          </a:fillRef>
-          <a:effectRef idx="2">
-            <a:schemeClr val="accent1"/>
-          </a:effectRef>
-          <a:fontRef idx="minor">
-            <a:schemeClr val="lt1"/>
-          </a:fontRef>
-        </p:style>
-        <p:txBody>
-          <a:bodyPr rtlCol="0" anchor="ctr" tIns="0" bIns="0"/>
-          <a:lstStyle/>
-          <a:p>
-            <a:pPr algn="l">
-              <a:spcAft>
-                <a:spcPts val="0"/>
-              </a:spcAft>
-            </a:pPr>
-            <a:r>
-              <a:rPr sz="1200" b="1" i="0">
-                <a:solidFill>
-                  <a:srgbClr val="FFFFFF"/>
-                </a:solidFill>
-                <a:latin typeface="Noto Sans Thai Looped"/>
-              </a:rPr>
-              <a:t>starter/coupons.go</a:t>
-            </a:r>
-          </a:p>
-        </p:txBody>
-      </p:sp>
-      <p:sp>
-        <p:nvSpPr>
-          <p:cNvPr id="6" name="TextBox 5"/>
-          <p:cNvSpPr txBox="1"/>
-          <p:nvPr/>
-        </p:nvSpPr>
-        <p:spPr>
-          <a:xfrm>
-            <a:off x="6858000" y="1920240"/>
-            <a:ext cx="4846320" cy="4114800"/>
-          </a:xfrm>
-          <a:prstGeom prst="rect">
-            <a:avLst/>
-          </a:prstGeom>
-          <a:noFill/>
-        </p:spPr>
-        <p:txBody>
-          <a:bodyPr wrap="square">
-            <a:spAutoFit/>
-          </a:bodyPr>
-          <a:lstStyle/>
-          <a:p>
-            <a:pPr algn="l">
-              <a:spcAft>
-                <a:spcPts val="600"/>
-              </a:spcAft>
-            </a:pPr>
-            <a:r>
-              <a:rPr sz="1800" b="1" i="0">
-                <a:solidFill>
-                  <a:srgbClr val="0D9488"/>
-                </a:solidFill>
-                <a:latin typeface="Noto Sans Thai Looped"/>
-              </a:rPr>
-              <a:t>โจทย์ของคุณ</a:t>
-            </a:r>
-          </a:p>
-          <a:p>
-            <a:pPr algn="l">
-              <a:spcAft>
-                <a:spcPts val="800"/>
-              </a:spcAft>
-            </a:pPr>
-            <a:r>
-              <a:rPr sz="1500" b="0" i="0">
-                <a:solidFill>
-                  <a:srgbClr val="0F172A"/>
-                </a:solidFill>
-                <a:latin typeface="Ubuntu"/>
-              </a:rPr>
-              <a:t>1.</a:t>
-            </a:r>
-            <a:r>
-              <a:rPr sz="1500" b="0" i="0">
-                <a:solidFill>
-                  <a:srgbClr val="0F172A"/>
-                </a:solidFill>
-                <a:latin typeface="Noto Sans Thai Looped"/>
-              </a:rPr>
-              <a:t> แยก A/C/D ให้ครบ (</a:t>
-            </a:r>
-            <a:r>
-              <a:rPr sz="1500" b="0" i="0">
-                <a:solidFill>
-                  <a:srgbClr val="0F172A"/>
-                </a:solidFill>
-                <a:latin typeface="Ubuntu"/>
-              </a:rPr>
-              <a:t>3</a:t>
-            </a:r>
-            <a:r>
-              <a:rPr sz="1500" b="0" i="0">
-                <a:solidFill>
-                  <a:srgbClr val="0F172A"/>
-                </a:solidFill>
-                <a:latin typeface="Noto Sans Thai Looped"/>
-              </a:rPr>
-              <a:t> น.)</a:t>
-            </a:r>
-          </a:p>
-          <a:p>
-            <a:pPr algn="l">
-              <a:spcAft>
-                <a:spcPts val="800"/>
-              </a:spcAft>
-            </a:pPr>
-            <a:r>
-              <a:rPr sz="1500" b="0" i="0">
-                <a:solidFill>
-                  <a:srgbClr val="0F172A"/>
-                </a:solidFill>
-                <a:latin typeface="Ubuntu"/>
-              </a:rPr>
-              <a:t>2.</a:t>
-            </a:r>
-            <a:r>
-              <a:rPr sz="1500" b="0" i="0">
-                <a:solidFill>
-                  <a:srgbClr val="0F172A"/>
-                </a:solidFill>
-                <a:latin typeface="Noto Sans Thai Looped"/>
-              </a:rPr>
-              <a:t> ดึง FindApplicableCoupons ออกมา — เขียน table-driven test ก่อน implementation (</a:t>
-            </a:r>
-            <a:r>
-              <a:rPr sz="1500" b="0" i="0">
-                <a:solidFill>
-                  <a:srgbClr val="0F172A"/>
-                </a:solidFill>
-                <a:latin typeface="Ubuntu"/>
-              </a:rPr>
-              <a:t>10</a:t>
-            </a:r>
-            <a:r>
-              <a:rPr sz="1500" b="0" i="0">
-                <a:solidFill>
-                  <a:srgbClr val="0F172A"/>
-                </a:solidFill>
-                <a:latin typeface="Noto Sans Thai Looped"/>
-              </a:rPr>
-              <a:t> น.)</a:t>
-            </a:r>
-          </a:p>
-          <a:p>
-            <a:pPr algn="l">
-              <a:spcAft>
-                <a:spcPts val="800"/>
-              </a:spcAft>
-            </a:pPr>
-            <a:r>
-              <a:rPr sz="1500" b="0" i="0">
-                <a:solidFill>
-                  <a:srgbClr val="0F172A"/>
-                </a:solidFill>
-                <a:latin typeface="Ubuntu"/>
-              </a:rPr>
-              <a:t>3.</a:t>
-            </a:r>
-            <a:r>
-              <a:rPr sz="1500" b="0" i="0">
-                <a:solidFill>
-                  <a:srgbClr val="0F172A"/>
-                </a:solidFill>
-                <a:latin typeface="Noto Sans Thai Looped"/>
-              </a:rPr>
-              <a:t> เหลือ SendCouponEmail เป็น action บาง ๆ (</a:t>
-            </a:r>
-            <a:r>
-              <a:rPr sz="1500" b="0" i="0">
-                <a:solidFill>
-                  <a:srgbClr val="0F172A"/>
-                </a:solidFill>
-                <a:latin typeface="Ubuntu"/>
-              </a:rPr>
-              <a:t>5</a:t>
-            </a:r>
-            <a:r>
-              <a:rPr sz="1500" b="0" i="0">
-                <a:solidFill>
-                  <a:srgbClr val="0F172A"/>
-                </a:solidFill>
-                <a:latin typeface="Noto Sans Thai Looped"/>
-              </a:rPr>
-              <a:t> น.)</a:t>
-            </a:r>
-          </a:p>
-          <a:p>
-            <a:pPr algn="l">
-              <a:spcAft>
-                <a:spcPts val="800"/>
-              </a:spcAft>
-            </a:pPr>
-            <a:r>
-              <a:rPr sz="1500" b="0" i="0">
-                <a:solidFill>
-                  <a:srgbClr val="0F172A"/>
-                </a:solidFill>
-                <a:latin typeface="Ubuntu"/>
-              </a:rPr>
-              <a:t>4.</a:t>
-            </a:r>
-            <a:r>
-              <a:rPr sz="1500" b="0" i="0">
-                <a:solidFill>
-                  <a:srgbClr val="0F172A"/>
-                </a:solidFill>
-                <a:latin typeface="Noto Sans Thai Looped"/>
-              </a:rPr>
-              <a:t> เทียบกับ solution/ (</a:t>
-            </a:r>
-            <a:r>
-              <a:rPr sz="1500" b="0" i="0">
-                <a:solidFill>
-                  <a:srgbClr val="0F172A"/>
-                </a:solidFill>
-                <a:latin typeface="Ubuntu"/>
-              </a:rPr>
-              <a:t>2</a:t>
-            </a:r>
-            <a:r>
-              <a:rPr sz="1500" b="0" i="0">
-                <a:solidFill>
-                  <a:srgbClr val="0F172A"/>
-                </a:solidFill>
-                <a:latin typeface="Noto Sans Thai Looped"/>
-              </a:rPr>
-              <a:t> น.)</a:t>
-            </a:r>
-          </a:p>
-          <a:p>
-            <a:pPr algn="l">
-              <a:spcAft>
-                <a:spcPts val="600"/>
-              </a:spcAft>
-            </a:pPr>
-            <a:r>
-              <a:rPr sz="1300" b="0" i="1">
-                <a:solidFill>
-                  <a:srgbClr val="64748B"/>
-                </a:solidFill>
-                <a:latin typeface="Noto Sans Thai Looped"/>
-              </a:rPr>
-              <a:t>กติกาโจทย์: เงินเป็นบาทเต็มไม่ติดลบ · coupon ไม่มีหมวด = ใช้ได้ทุกหมวด · รักษาลำดับเดิม</a:t>
-            </a:r>
-          </a:p>
-        </p:txBody>
-      </p:sp>
-    </p:spTree>
-  </p:cSld>
-  <p:clrMapOvr>
-    <a:masterClrMapping/>
-  </p:clrMapOvr>
-</p:sld>
-</file>
-
-<file path=ppt/slides/slide14.xml><?xml version="1.0" encoding="utf-8"?>
-<p:sld xmlns:a="http://schemas.openxmlformats.org/drawingml/2006/main" xmlns:p="http://schemas.openxmlformats.org/presentationml/2006/main" xmlns:r="http://schemas.openxmlformats.org/officeDocument/2006/relationships">
-  <p:cSld>
-    <p:spTree>
-      <p:nvGrpSpPr>
-        <p:cNvPr id="1" name=""/>
-        <p:cNvGrpSpPr/>
-        <p:nvPr/>
-      </p:nvGrpSpPr>
-      <p:grpSpPr/>
-      <p:sp>
-        <p:nvSpPr>
-          <p:cNvPr id="2" name="TextBox 1"/>
-          <p:cNvSpPr txBox="1"/>
-          <p:nvPr/>
-        </p:nvSpPr>
-        <p:spPr>
-          <a:xfrm>
-            <a:off x="502920" y="292608"/>
-            <a:ext cx="11155680" cy="914400"/>
-          </a:xfrm>
-          <a:prstGeom prst="rect">
-            <a:avLst/>
-          </a:prstGeom>
-          <a:noFill/>
-        </p:spPr>
-        <p:txBody>
-          <a:bodyPr wrap="square">
-            <a:spAutoFit/>
-          </a:bodyPr>
-          <a:lstStyle/>
-          <a:p>
-            <a:pPr algn="l">
-              <a:spcAft>
-                <a:spcPts val="200"/>
-              </a:spcAft>
-            </a:pPr>
-            <a:r>
-              <a:rPr sz="3000" b="1" i="0">
-                <a:solidFill>
-                  <a:srgbClr val="0F172A"/>
-                </a:solidFill>
-                <a:latin typeface="Noto Sans Thai Looped"/>
-              </a:rPr>
-              <a:t>เฉลย: calculation ที่ pure เต็มตัว + action ที่บางที่สุด</a:t>
-            </a:r>
-          </a:p>
-        </p:txBody>
-      </p:sp>
-      <p:sp>
-        <p:nvSpPr>
-          <p:cNvPr id="3" name="Rectangle 2"/>
-          <p:cNvSpPr/>
-          <p:nvPr/>
-        </p:nvSpPr>
-        <p:spPr>
-          <a:xfrm>
-            <a:off x="502920" y="1207008"/>
-            <a:ext cx="11201400" cy="27940"/>
-          </a:xfrm>
-          <a:prstGeom prst="rect">
-            <a:avLst/>
-          </a:prstGeom>
-          <a:solidFill>
-            <a:srgbClr val="0D9488"/>
-          </a:solidFill>
-          <a:ln>
-            <a:noFill/>
-          </a:ln>
-        </p:spPr>
-        <p:style>
-          <a:lnRef idx="1">
-            <a:schemeClr val="accent1"/>
-          </a:lnRef>
-          <a:fillRef idx="3">
-            <a:schemeClr val="accent1"/>
-          </a:fillRef>
-          <a:effectRef idx="2">
-            <a:schemeClr val="accent1"/>
-          </a:effectRef>
-          <a:fontRef idx="minor">
-            <a:schemeClr val="lt1"/>
-          </a:fontRef>
-        </p:style>
-        <p:txBody>
-          <a:bodyPr rtlCol="0" anchor="ctr"/>
-          <a:lstStyle/>
-          <a:p>
-            <a:pPr algn="ctr"/>
-          </a:p>
-        </p:txBody>
-      </p:sp>
-      <p:sp>
-        <p:nvSpPr>
-          <p:cNvPr id="4" name="Rounded Rectangle 3"/>
-          <p:cNvSpPr/>
-          <p:nvPr/>
-        </p:nvSpPr>
-        <p:spPr>
-          <a:xfrm>
-            <a:off x="548640" y="1691640"/>
-            <a:ext cx="7132320" cy="4023360"/>
-          </a:xfrm>
-          <a:prstGeom prst="roundRect">
-            <a:avLst/>
-          </a:prstGeom>
-          <a:solidFill>
-            <a:srgbClr val="1E1E2E"/>
-          </a:solidFill>
-          <a:ln>
-            <a:noFill/>
-          </a:ln>
-          <a:effectLst/>
-        </p:spPr>
-        <p:style>
-          <a:lnRef idx="1">
-            <a:schemeClr val="accent1"/>
-          </a:lnRef>
-          <a:fillRef idx="3">
-            <a:schemeClr val="accent1"/>
-          </a:fillRef>
-          <a:effectRef idx="2">
-            <a:schemeClr val="accent1"/>
-          </a:effectRef>
-          <a:fontRef idx="minor">
-            <a:schemeClr val="lt1"/>
-          </a:fontRef>
-        </p:style>
-        <p:txBody>
-          <a:bodyPr rtlCol="0" anchor="t" wrap="none" lIns="164592" rIns="109728" tIns="109728"/>
-          <a:lstStyle/>
-          <a:p>
-            <a:pPr algn="l">
-              <a:spcAft>
-                <a:spcPts val="0"/>
-              </a:spcAft>
-            </a:pPr>
-            <a:r>
-              <a:rPr sz="1300" i="1">
-                <a:solidFill>
-                  <a:srgbClr val="94A3B8"/>
-                </a:solidFill>
-                <a:latin typeface="DejaVu Sans Mono"/>
-              </a:rPr>
-              <a:t>// Calculation — pure: input เดิม ได้คูปองชุดเดิมเสมอ</a:t>
-            </a:r>
-          </a:p>
-          <a:p>
-            <a:pPr algn="l">
-              <a:spcAft>
-                <a:spcPts val="0"/>
-              </a:spcAft>
-            </a:pPr>
-            <a:r>
-              <a:rPr sz="1300" i="0">
-                <a:solidFill>
-                  <a:srgbClr val="E2E8F0"/>
-                </a:solidFill>
-                <a:latin typeface="DejaVu Sans Mono"/>
-              </a:rPr>
-              <a:t>func FindApplicableCoupons(cart Cart,</a:t>
-            </a:r>
-          </a:p>
-          <a:p>
-            <a:pPr algn="l">
-              <a:spcAft>
-                <a:spcPts val="0"/>
-              </a:spcAft>
-            </a:pPr>
-            <a:r>
-              <a:rPr sz="1300" i="0">
-                <a:solidFill>
-                  <a:srgbClr val="E2E8F0"/>
-                </a:solidFill>
-                <a:latin typeface="DejaVu Sans Mono"/>
-              </a:rPr>
-              <a:t>    coupons []Coupon) []Coupon {</a:t>
-            </a:r>
-          </a:p>
-          <a:p>
-            <a:pPr algn="l">
-              <a:spcAft>
-                <a:spcPts val="0"/>
-              </a:spcAft>
-            </a:pPr>
-            <a:r>
-              <a:rPr sz="1300" i="0">
-                <a:solidFill>
-                  <a:srgbClr val="E2E8F0"/>
-                </a:solidFill>
-                <a:latin typeface="DejaVu Sans Mono"/>
-              </a:rPr>
-              <a:t>    result := make([]Coupon, 0)</a:t>
-            </a:r>
-          </a:p>
-          <a:p>
-            <a:pPr algn="l">
-              <a:spcAft>
-                <a:spcPts val="0"/>
-              </a:spcAft>
-            </a:pPr>
-            <a:r>
-              <a:rPr sz="1300" i="0">
-                <a:solidFill>
-                  <a:srgbClr val="E2E8F0"/>
-                </a:solidFill>
-                <a:latin typeface="DejaVu Sans Mono"/>
-              </a:rPr>
-              <a:t>    for _, c := range coupons {</a:t>
-            </a:r>
-          </a:p>
-          <a:p>
-            <a:pPr algn="l">
-              <a:spcAft>
-                <a:spcPts val="0"/>
-              </a:spcAft>
-            </a:pPr>
-            <a:r>
-              <a:rPr sz="1300" i="0">
-                <a:solidFill>
-                  <a:srgbClr val="E2E8F0"/>
-                </a:solidFill>
-                <a:latin typeface="DejaVu Sans Mono"/>
-              </a:rPr>
-              <a:t>        if cart.Total &gt;= c.MinimumTotal &amp;&amp;</a:t>
-            </a:r>
-          </a:p>
-          <a:p>
-            <a:pPr algn="l">
-              <a:spcAft>
-                <a:spcPts val="0"/>
-              </a:spcAft>
-            </a:pPr>
-            <a:r>
-              <a:rPr sz="1300" i="0">
-                <a:solidFill>
-                  <a:srgbClr val="E2E8F0"/>
-                </a:solidFill>
-                <a:latin typeface="DejaVu Sans Mono"/>
-              </a:rPr>
-              <a:t>            (c.Category == "" || c.Category == cart.Category) {</a:t>
-            </a:r>
-          </a:p>
-          <a:p>
-            <a:pPr algn="l">
-              <a:spcAft>
-                <a:spcPts val="0"/>
-              </a:spcAft>
-            </a:pPr>
-            <a:r>
-              <a:rPr sz="1300" i="0">
-                <a:solidFill>
-                  <a:srgbClr val="E2E8F0"/>
-                </a:solidFill>
-                <a:latin typeface="DejaVu Sans Mono"/>
-              </a:rPr>
-              <a:t>            result = append(result, c)</a:t>
-            </a:r>
-          </a:p>
-          <a:p>
-            <a:pPr algn="l">
-              <a:spcAft>
-                <a:spcPts val="0"/>
-              </a:spcAft>
-            </a:pPr>
-            <a:r>
-              <a:rPr sz="1300" i="0">
-                <a:solidFill>
-                  <a:srgbClr val="E2E8F0"/>
-                </a:solidFill>
-                <a:latin typeface="DejaVu Sans Mono"/>
-              </a:rPr>
-              <a:t>        }</a:t>
-            </a:r>
-          </a:p>
-          <a:p>
-            <a:pPr algn="l">
-              <a:spcAft>
-                <a:spcPts val="0"/>
-              </a:spcAft>
-            </a:pPr>
-            <a:r>
-              <a:rPr sz="1300" i="0">
-                <a:solidFill>
-                  <a:srgbClr val="E2E8F0"/>
-                </a:solidFill>
-                <a:latin typeface="DejaVu Sans Mono"/>
-              </a:rPr>
-              <a:t>    }</a:t>
-            </a:r>
-          </a:p>
-          <a:p>
-            <a:pPr algn="l">
-              <a:spcAft>
-                <a:spcPts val="0"/>
-              </a:spcAft>
-            </a:pPr>
-            <a:r>
-              <a:rPr sz="1300" i="0">
-                <a:solidFill>
-                  <a:srgbClr val="E2E8F0"/>
-                </a:solidFill>
-                <a:latin typeface="DejaVu Sans Mono"/>
-              </a:rPr>
-              <a:t>    return result</a:t>
-            </a:r>
-          </a:p>
-          <a:p>
-            <a:pPr algn="l">
-              <a:spcAft>
-                <a:spcPts val="0"/>
-              </a:spcAft>
-            </a:pPr>
-            <a:r>
-              <a:rPr sz="1300" i="0">
-                <a:solidFill>
-                  <a:srgbClr val="E2E8F0"/>
-                </a:solidFill>
-                <a:latin typeface="DejaVu Sans Mono"/>
-              </a:rPr>
-              <a:t>}</a:t>
-            </a:r>
-          </a:p>
-          <a:p>
-            <a:pPr algn="l">
-              <a:spcAft>
-                <a:spcPts val="0"/>
-              </a:spcAft>
-            </a:pPr>
-          </a:p>
-          <a:p>
-            <a:pPr algn="l">
-              <a:spcAft>
-                <a:spcPts val="0"/>
-              </a:spcAft>
-            </a:pPr>
-            <a:r>
-              <a:rPr sz="1300" i="1">
-                <a:solidFill>
-                  <a:srgbClr val="94A3B8"/>
-                </a:solidFill>
-                <a:latin typeface="DejaVu Sans Mono"/>
-              </a:rPr>
-              <a:t>// Action — เหลือแค่ "จุดที่โลกเปลี่ยน"</a:t>
-            </a:r>
-          </a:p>
-          <a:p>
-            <a:pPr algn="l">
-              <a:spcAft>
-                <a:spcPts val="0"/>
-              </a:spcAft>
-            </a:pPr>
-            <a:r>
-              <a:rPr sz="1300" i="0">
-                <a:solidFill>
-                  <a:srgbClr val="E2E8F0"/>
-                </a:solidFill>
-                <a:latin typeface="DejaVu Sans Mono"/>
-              </a:rPr>
-              <a:t>func SendCouponEmail(out io.Writer, email string,</a:t>
-            </a:r>
-          </a:p>
-          <a:p>
-            <a:pPr algn="l">
-              <a:spcAft>
-                <a:spcPts val="0"/>
-              </a:spcAft>
-            </a:pPr>
-            <a:r>
-              <a:rPr sz="1300" i="0">
-                <a:solidFill>
-                  <a:srgbClr val="E2E8F0"/>
-                </a:solidFill>
-                <a:latin typeface="DejaVu Sans Mono"/>
-              </a:rPr>
-              <a:t>    coupons []Coupon) error { ... }</a:t>
-            </a:r>
-          </a:p>
-        </p:txBody>
-      </p:sp>
-      <p:sp>
-        <p:nvSpPr>
-          <p:cNvPr id="5" name="Rounded Rectangle 4"/>
-          <p:cNvSpPr/>
-          <p:nvPr/>
-        </p:nvSpPr>
-        <p:spPr>
-          <a:xfrm>
-            <a:off x="548640" y="1380744"/>
-            <a:ext cx="1271016" cy="274320"/>
-          </a:xfrm>
-          <a:prstGeom prst="roundRect">
-            <a:avLst/>
-          </a:prstGeom>
-          <a:solidFill>
-            <a:srgbClr val="16A34A"/>
-          </a:solidFill>
-          <a:ln>
-            <a:noFill/>
-          </a:ln>
-          <a:effectLst/>
-        </p:spPr>
-        <p:style>
-          <a:lnRef idx="1">
-            <a:schemeClr val="accent1"/>
-          </a:lnRef>
-          <a:fillRef idx="3">
-            <a:schemeClr val="accent1"/>
-          </a:fillRef>
-          <a:effectRef idx="2">
-            <a:schemeClr val="accent1"/>
-          </a:effectRef>
-          <a:fontRef idx="minor">
-            <a:schemeClr val="lt1"/>
-          </a:fontRef>
-        </p:style>
-        <p:txBody>
-          <a:bodyPr rtlCol="0" anchor="ctr" tIns="0" bIns="0"/>
-          <a:lstStyle/>
-          <a:p>
-            <a:pPr algn="l">
-              <a:spcAft>
-                <a:spcPts val="0"/>
-              </a:spcAft>
-            </a:pPr>
-            <a:r>
-              <a:rPr sz="1200" b="1" i="0">
-                <a:solidFill>
-                  <a:srgbClr val="FFFFFF"/>
-                </a:solidFill>
-                <a:latin typeface="Noto Sans Thai Looped"/>
-              </a:rPr>
-              <a:t>solution/</a:t>
-            </a:r>
-          </a:p>
-        </p:txBody>
-      </p:sp>
-      <p:sp>
-        <p:nvSpPr>
-          <p:cNvPr id="6" name="TextBox 5"/>
-          <p:cNvSpPr txBox="1"/>
-          <p:nvPr/>
-        </p:nvSpPr>
-        <p:spPr>
-          <a:xfrm>
-            <a:off x="8001000" y="1828800"/>
-            <a:ext cx="3657600" cy="3840480"/>
-          </a:xfrm>
-          <a:prstGeom prst="rect">
-            <a:avLst/>
-          </a:prstGeom>
-          <a:noFill/>
-        </p:spPr>
-        <p:txBody>
-          <a:bodyPr wrap="square">
-            <a:spAutoFit/>
-          </a:bodyPr>
-          <a:lstStyle/>
-          <a:p>
-            <a:pPr algn="l">
-              <a:spcAft>
-                <a:spcPts val="800"/>
-              </a:spcAft>
-            </a:pPr>
-            <a:r>
-              <a:rPr sz="1800" b="1" i="0">
-                <a:solidFill>
-                  <a:srgbClr val="0D9488"/>
-                </a:solidFill>
-                <a:latin typeface="Noto Sans Thai Looped"/>
-              </a:rPr>
-              <a:t>สังเกต</a:t>
-            </a:r>
-          </a:p>
-          <a:p>
-            <a:pPr algn="l">
-              <a:spcAft>
-                <a:spcPts val="1000"/>
-              </a:spcAft>
-            </a:pPr>
-            <a:r>
-              <a:rPr sz="1500" b="0" i="0">
-                <a:solidFill>
-                  <a:srgbClr val="0F172A"/>
-                </a:solidFill>
-                <a:latin typeface="Noto Sans Thai Looped"/>
-              </a:rPr>
-              <a:t>• กติกาธุรกิจทั้งหมดอยู่ใน calculation เดียว เทสต์ได้โดยไม่แตะ I/O</a:t>
-            </a:r>
-          </a:p>
-          <a:p>
-            <a:pPr algn="l">
-              <a:spcAft>
-                <a:spcPts val="1000"/>
-              </a:spcAft>
-            </a:pPr>
-            <a:r>
-              <a:rPr sz="1500" b="0" i="0">
-                <a:solidFill>
-                  <a:srgbClr val="0F172A"/>
-                </a:solidFill>
-                <a:latin typeface="Noto Sans Thai Looped"/>
-              </a:rPr>
-              <a:t>• SendCouponEmail รู้จักแค่การ 'ส่ง' — ไม่รู้ว่าคูปองมายังไง</a:t>
-            </a:r>
-          </a:p>
-          <a:p>
-            <a:pPr algn="l">
-              <a:spcAft>
-                <a:spcPts val="1000"/>
-              </a:spcAft>
-            </a:pPr>
-            <a:r>
-              <a:rPr sz="1500" b="0" i="0">
-                <a:solidFill>
-                  <a:srgbClr val="0F172A"/>
-                </a:solidFill>
-                <a:latin typeface="Noto Sans Thai Looped"/>
-              </a:rPr>
-              <a:t>• ลำดับการเรียก (หาก่อน → ส่งทีหลัง) เป็นของผู้เรียก ไม่ใช่ของฟังก์ชัน</a:t>
-            </a:r>
-          </a:p>
-        </p:txBody>
-      </p:sp>
-    </p:spTree>
-  </p:cSld>
-  <p:clrMapOvr>
-    <a:masterClrMapping/>
-  </p:clrMapOvr>
-</p:sld>
-</file>
-
-<file path=ppt/slides/slide15.xml><?xml version="1.0" encoding="utf-8"?>
-<p:sld xmlns:a="http://schemas.openxmlformats.org/drawingml/2006/main" xmlns:p="http://schemas.openxmlformats.org/presentationml/2006/main" xmlns:r="http://schemas.openxmlformats.org/officeDocument/2006/relationships">
-  <p:cSld>
-    <p:spTree>
-      <p:nvGrpSpPr>
-        <p:cNvPr id="1" name=""/>
-        <p:cNvGrpSpPr/>
-        <p:nvPr/>
-      </p:nvGrpSpPr>
-      <p:grpSpPr/>
-      <p:sp>
-        <p:nvSpPr>
-          <p:cNvPr id="2" name="TextBox 1"/>
-          <p:cNvSpPr txBox="1"/>
-          <p:nvPr/>
-        </p:nvSpPr>
-        <p:spPr>
-          <a:xfrm>
-            <a:off x="502920" y="292608"/>
-            <a:ext cx="11155680" cy="914400"/>
-          </a:xfrm>
-          <a:prstGeom prst="rect">
-            <a:avLst/>
-          </a:prstGeom>
-          <a:noFill/>
-        </p:spPr>
-        <p:txBody>
-          <a:bodyPr wrap="square">
-            <a:spAutoFit/>
-          </a:bodyPr>
-          <a:lstStyle/>
-          <a:p>
-            <a:pPr algn="l">
-              <a:spcAft>
-                <a:spcPts val="200"/>
-              </a:spcAft>
-            </a:pPr>
-            <a:r>
-              <a:rPr sz="3000" b="1" i="0">
-                <a:solidFill>
-                  <a:srgbClr val="0F172A"/>
-                </a:solidFill>
-                <a:latin typeface="Noto Sans Thai Looped"/>
-              </a:rPr>
               <a:t>ของหวาน: Lazy Sequence ด้วย iter.Seq (Go </a:t>
             </a:r>
             <a:r>
@@ -8122,7 +6802,7 @@
 </p:sld>
 </file>
 
-<file path=ppt/slides/slide16.xml><?xml version="1.0" encoding="utf-8"?>
+<file path=ppt/slides/slide14.xml><?xml version="1.0" encoding="utf-8"?>
 <p:sld xmlns:a="http://schemas.openxmlformats.org/drawingml/2006/main" xmlns:p="http://schemas.openxmlformats.org/presentationml/2006/main" xmlns:r="http://schemas.openxmlformats.org/officeDocument/2006/relationships">
   <p:cSld>
     <p:spTree>
@@ -8663,7 +7343,7 @@
 </p:sld>
 </file>
 
-<file path=ppt/slides/slide17.xml><?xml version="1.0" encoding="utf-8"?>
+<file path=ppt/slides/slide15.xml><?xml version="1.0" encoding="utf-8"?>
 <p:sld xmlns:a="http://schemas.openxmlformats.org/drawingml/2006/main" xmlns:p="http://schemas.openxmlformats.org/presentationml/2006/main" xmlns:r="http://schemas.openxmlformats.org/officeDocument/2006/relationships">
   <p:cSld>
     <p:spTree>
@@ -8707,7 +7387,59 @@
                 </a:solidFill>
                 <a:latin typeface="Noto Sans Thai Looped"/>
               </a:rPr>
-              <a:t>อ่านต่อ</a:t>
+              <a:t>การบ้าน: แยกคูปองออกจากการส่งอีเมล</a:t>
+            </a:r>
+          </a:p>
+          <a:p>
+            <a:pPr algn="l">
+              <a:spcAft>
+                <a:spcPts val="600"/>
+              </a:spcAft>
+            </a:pPr>
+            <a:r>
+              <a:rPr sz="1500" b="0" i="0">
+                <a:solidFill>
+                  <a:srgbClr val="64748B"/>
+                </a:solidFill>
+                <a:latin typeface="Noto Sans Thai Looped"/>
+              </a:rPr>
+              <a:t>โจทย์จาก Grokking Simplicity บท </a:t>
+            </a:r>
+            <a:r>
+              <a:rPr sz="1500" b="0" i="0">
+                <a:solidFill>
+                  <a:srgbClr val="64748B"/>
+                </a:solidFill>
+                <a:latin typeface="Ubuntu"/>
+              </a:rPr>
+              <a:t>3–5</a:t>
+            </a:r>
+            <a:r>
+              <a:rPr sz="1500" b="0" i="0">
+                <a:solidFill>
+                  <a:srgbClr val="64748B"/>
+                </a:solidFill>
+                <a:latin typeface="Noto Sans Thai Looped"/>
+              </a:rPr>
+              <a:t> พอร์ตเป็น Go — repo: go-fp/</a:t>
+            </a:r>
+            <a:r>
+              <a:rPr sz="1500" b="0" i="0">
+                <a:solidFill>
+                  <a:srgbClr val="64748B"/>
+                </a:solidFill>
+                <a:latin typeface="Ubuntu"/>
+              </a:rPr>
+              <a:t>07-</a:t>
+            </a:r>
+            <a:r>
+              <a:rPr sz="1500" b="0" i="0">
+                <a:solidFill>
+                  <a:srgbClr val="64748B"/>
+                </a:solidFill>
+                <a:latin typeface="Noto Sans Thai Looped"/>
+              </a:rPr>
+              <a:t>coupon-email-exercise (มี EXERCISE.md ประกอบ)</a:t>
             </a:r>
           </a:p>
         </p:txBody>
@@ -8757,14 +7489,352 @@
       </p:sp>
       <p:sp>
         <p:nvSpPr>
-          <p:cNvPr id="4" name="TextBox 3"/>
+          <p:cNvPr id="4" name="Rounded Rectangle 3"/>
+          <p:cNvSpPr/>
+          <p:nvPr/>
+        </p:nvSpPr>
+        <p:spPr>
+          <a:xfrm>
+            <a:off x="548640" y="1874519"/>
+            <a:ext cx="6035040" cy="4114800"/>
+          </a:xfrm>
+          <a:prstGeom prst="roundRect">
+            <a:avLst/>
+          </a:prstGeom>
+          <a:solidFill>
+            <a:srgbClr val="1E1E2E"/>
+          </a:solidFill>
+          <a:ln>
+            <a:noFill/>
+          </a:ln>
+          <a:effectLst/>
+        </p:spPr>
+        <p:style>
+          <a:lnRef idx="1">
+            <a:schemeClr val="accent1"/>
+          </a:lnRef>
+          <a:fillRef idx="3">
+            <a:schemeClr val="accent1"/>
+          </a:fillRef>
+          <a:effectRef idx="2">
+            <a:schemeClr val="accent1"/>
+          </a:effectRef>
+          <a:fontRef idx="minor">
+            <a:schemeClr val="lt1"/>
+          </a:fontRef>
+        </p:style>
+        <p:txBody>
+          <a:bodyPr rtlCol="0" anchor="t" wrap="none" lIns="164592" rIns="109728" tIns="109728"/>
+          <a:lstStyle/>
+          <a:p>
+            <a:pPr algn="l">
+              <a:spcAft>
+                <a:spcPts val="0"/>
+              </a:spcAft>
+            </a:pPr>
+            <a:r>
+              <a:rPr sz="1200" i="1">
+                <a:solidFill>
+                  <a:srgbClr val="94A3B8"/>
+                </a:solidFill>
+                <a:latin typeface="DejaVu Sans Mono"/>
+              </a:rPr>
+              <a:t>// ทุกอย่างอยู่ในฟังก์ชันเดียว — มองแล้วเจออะไรบ้าง?</a:t>
+            </a:r>
+          </a:p>
+          <a:p>
+            <a:pPr algn="l">
+              <a:spcAft>
+                <a:spcPts val="0"/>
+              </a:spcAft>
+            </a:pPr>
+            <a:r>
+              <a:rPr sz="1200" i="0">
+                <a:solidFill>
+                  <a:srgbClr val="E2E8F0"/>
+                </a:solidFill>
+                <a:latin typeface="DejaVu Sans Mono"/>
+              </a:rPr>
+              <a:t>func EmailCoupons(cart Cart, coupons []Coupon,</a:t>
+            </a:r>
+          </a:p>
+          <a:p>
+            <a:pPr algn="l">
+              <a:spcAft>
+                <a:spcPts val="0"/>
+              </a:spcAft>
+            </a:pPr>
+            <a:r>
+              <a:rPr sz="1200" i="0">
+                <a:solidFill>
+                  <a:srgbClr val="E2E8F0"/>
+                </a:solidFill>
+                <a:latin typeface="DejaVu Sans Mono"/>
+              </a:rPr>
+              <a:t>    out io.Writer) error {</a:t>
+            </a:r>
+          </a:p>
+          <a:p>
+            <a:pPr algn="l">
+              <a:spcAft>
+                <a:spcPts val="0"/>
+              </a:spcAft>
+            </a:pPr>
+            <a:r>
+              <a:rPr sz="1200" i="0">
+                <a:solidFill>
+                  <a:srgbClr val="E2E8F0"/>
+                </a:solidFill>
+                <a:latin typeface="DejaVu Sans Mono"/>
+              </a:rPr>
+              <a:t>    fmt.Printf("finding coupons for %s\n", cart.Email)</a:t>
+            </a:r>
+          </a:p>
+          <a:p>
+            <a:pPr algn="l">
+              <a:spcAft>
+                <a:spcPts val="0"/>
+              </a:spcAft>
+            </a:pPr>
+            <a:r>
+              <a:rPr sz="1200" i="0">
+                <a:solidFill>
+                  <a:srgbClr val="E2E8F0"/>
+                </a:solidFill>
+                <a:latin typeface="DejaVu Sans Mono"/>
+              </a:rPr>
+              <a:t>    var codes []string</a:t>
+            </a:r>
+          </a:p>
+          <a:p>
+            <a:pPr algn="l">
+              <a:spcAft>
+                <a:spcPts val="0"/>
+              </a:spcAft>
+            </a:pPr>
+            <a:r>
+              <a:rPr sz="1200" i="0">
+                <a:solidFill>
+                  <a:srgbClr val="E2E8F0"/>
+                </a:solidFill>
+                <a:latin typeface="DejaVu Sans Mono"/>
+              </a:rPr>
+              <a:t>    for _, c := range coupons {</a:t>
+            </a:r>
+          </a:p>
+          <a:p>
+            <a:pPr algn="l">
+              <a:spcAft>
+                <a:spcPts val="0"/>
+              </a:spcAft>
+            </a:pPr>
+            <a:r>
+              <a:rPr sz="1200" i="0">
+                <a:solidFill>
+                  <a:srgbClr val="E2E8F0"/>
+                </a:solidFill>
+                <a:latin typeface="DejaVu Sans Mono"/>
+              </a:rPr>
+              <a:t>        if cart.Total &gt;= c.MinimumTotal &amp;&amp;</a:t>
+            </a:r>
+          </a:p>
+          <a:p>
+            <a:pPr algn="l">
+              <a:spcAft>
+                <a:spcPts val="0"/>
+              </a:spcAft>
+            </a:pPr>
+            <a:r>
+              <a:rPr sz="1200" i="0">
+                <a:solidFill>
+                  <a:srgbClr val="E2E8F0"/>
+                </a:solidFill>
+                <a:latin typeface="DejaVu Sans Mono"/>
+              </a:rPr>
+              <a:t>            (c.Category == "" || c.Category == cart.Category) {</a:t>
+            </a:r>
+          </a:p>
+          <a:p>
+            <a:pPr algn="l">
+              <a:spcAft>
+                <a:spcPts val="0"/>
+              </a:spcAft>
+            </a:pPr>
+            <a:r>
+              <a:rPr sz="1200" i="0">
+                <a:solidFill>
+                  <a:srgbClr val="E2E8F0"/>
+                </a:solidFill>
+                <a:latin typeface="DejaVu Sans Mono"/>
+              </a:rPr>
+              <a:t>            codes = append(codes, c.Code)</a:t>
+            </a:r>
+          </a:p>
+          <a:p>
+            <a:pPr algn="l">
+              <a:spcAft>
+                <a:spcPts val="0"/>
+              </a:spcAft>
+            </a:pPr>
+            <a:r>
+              <a:rPr sz="1200" i="0">
+                <a:solidFill>
+                  <a:srgbClr val="E2E8F0"/>
+                </a:solidFill>
+                <a:latin typeface="DejaVu Sans Mono"/>
+              </a:rPr>
+              <a:t>        }</a:t>
+            </a:r>
+          </a:p>
+          <a:p>
+            <a:pPr algn="l">
+              <a:spcAft>
+                <a:spcPts val="0"/>
+              </a:spcAft>
+            </a:pPr>
+            <a:r>
+              <a:rPr sz="1200" i="0">
+                <a:solidFill>
+                  <a:srgbClr val="E2E8F0"/>
+                </a:solidFill>
+                <a:latin typeface="DejaVu Sans Mono"/>
+              </a:rPr>
+              <a:t>    }</a:t>
+            </a:r>
+          </a:p>
+          <a:p>
+            <a:pPr algn="l">
+              <a:spcAft>
+                <a:spcPts val="0"/>
+              </a:spcAft>
+            </a:pPr>
+            <a:r>
+              <a:rPr sz="1200" i="0">
+                <a:solidFill>
+                  <a:srgbClr val="E2E8F0"/>
+                </a:solidFill>
+                <a:latin typeface="DejaVu Sans Mono"/>
+              </a:rPr>
+              <a:t>    _, err := fmt.Fprintf(out,</a:t>
+            </a:r>
+          </a:p>
+          <a:p>
+            <a:pPr algn="l">
+              <a:spcAft>
+                <a:spcPts val="0"/>
+              </a:spcAft>
+            </a:pPr>
+            <a:r>
+              <a:rPr sz="1200" i="0">
+                <a:solidFill>
+                  <a:srgbClr val="E2E8F0"/>
+                </a:solidFill>
+                <a:latin typeface="DejaVu Sans Mono"/>
+              </a:rPr>
+              <a:t>        "To: %s\nCoupons: %v\n", cart.Email, codes)</a:t>
+            </a:r>
+          </a:p>
+          <a:p>
+            <a:pPr algn="l">
+              <a:spcAft>
+                <a:spcPts val="0"/>
+              </a:spcAft>
+            </a:pPr>
+            <a:r>
+              <a:rPr sz="1200" i="0">
+                <a:solidFill>
+                  <a:srgbClr val="E2E8F0"/>
+                </a:solidFill>
+                <a:latin typeface="DejaVu Sans Mono"/>
+              </a:rPr>
+              <a:t>    return err</a:t>
+            </a:r>
+          </a:p>
+          <a:p>
+            <a:pPr algn="l">
+              <a:spcAft>
+                <a:spcPts val="0"/>
+              </a:spcAft>
+            </a:pPr>
+            <a:r>
+              <a:rPr sz="1200" i="0">
+                <a:solidFill>
+                  <a:srgbClr val="E2E8F0"/>
+                </a:solidFill>
+                <a:latin typeface="DejaVu Sans Mono"/>
+              </a:rPr>
+              <a:t>}</a:t>
+            </a:r>
+          </a:p>
+        </p:txBody>
+      </p:sp>
+      <p:sp>
+        <p:nvSpPr>
+          <p:cNvPr id="5" name="Rounded Rectangle 4"/>
+          <p:cNvSpPr/>
+          <p:nvPr/>
+        </p:nvSpPr>
+        <p:spPr>
+          <a:xfrm>
+            <a:off x="548640" y="1563623"/>
+            <a:ext cx="3483864" cy="274320"/>
+          </a:xfrm>
+          <a:prstGeom prst="roundRect">
+            <a:avLst/>
+          </a:prstGeom>
+          <a:solidFill>
+            <a:srgbClr val="DC2626"/>
+          </a:solidFill>
+          <a:ln>
+            <a:noFill/>
+          </a:ln>
+          <a:effectLst/>
+        </p:spPr>
+        <p:style>
+          <a:lnRef idx="1">
+            <a:schemeClr val="accent1"/>
+          </a:lnRef>
+          <a:fillRef idx="3">
+            <a:schemeClr val="accent1"/>
+          </a:fillRef>
+          <a:effectRef idx="2">
+            <a:schemeClr val="accent1"/>
+          </a:effectRef>
+          <a:fontRef idx="minor">
+            <a:schemeClr val="lt1"/>
+          </a:fontRef>
+        </p:style>
+        <p:txBody>
+          <a:bodyPr rtlCol="0" anchor="ctr" tIns="0" bIns="0"/>
+          <a:lstStyle/>
+          <a:p>
+            <a:pPr algn="l">
+              <a:spcAft>
+                <a:spcPts val="0"/>
+              </a:spcAft>
+            </a:pPr>
+            <a:r>
+              <a:rPr sz="1200" b="1" i="0">
+                <a:solidFill>
+                  <a:srgbClr val="FFFFFF"/>
+                </a:solidFill>
+                <a:latin typeface="Noto Sans Thai Looped"/>
+              </a:rPr>
+              <a:t>starter/coupons.go — จุดตั้งต้น</a:t>
+            </a:r>
+          </a:p>
+        </p:txBody>
+      </p:sp>
+      <p:sp>
+        <p:nvSpPr>
+          <p:cNvPr id="6" name="TextBox 5"/>
           <p:cNvSpPr txBox="1"/>
           <p:nvPr/>
         </p:nvSpPr>
         <p:spPr>
           <a:xfrm>
-            <a:off x="548640" y="1645920"/>
-            <a:ext cx="11064240" cy="4937760"/>
+            <a:off x="6858000" y="1920240"/>
+            <a:ext cx="4846320" cy="4114800"/>
           </a:xfrm>
           <a:prstGeom prst="rect">
             <a:avLst/>
@@ -8779,228 +7849,190 @@
           <a:p>
             <a:pPr algn="l">
               <a:spcAft>
+                <a:spcPts val="600"/>
+              </a:spcAft>
+            </a:pPr>
+            <a:r>
+              <a:rPr sz="1800" b="1" i="0">
+                <a:solidFill>
+                  <a:srgbClr val="0D9488"/>
+                </a:solidFill>
+                <a:latin typeface="Noto Sans Thai Looped"/>
+              </a:rPr>
+              <a:t>โจทย์ของคุณ</a:t>
+            </a:r>
+          </a:p>
+          <a:p>
+            <a:pPr algn="l">
+              <a:spcAft>
                 <a:spcPts val="800"/>
               </a:spcAft>
             </a:pPr>
             <a:r>
-              <a:rPr sz="1700" b="0" i="0">
+              <a:rPr sz="1500" b="0" i="0">
                 <a:solidFill>
                   <a:srgbClr val="0F172A"/>
                 </a:solidFill>
+                <a:latin typeface="Ubuntu"/>
+              </a:rPr>
+              <a:t>1.</a:t>
+            </a:r>
+            <a:r>
+              <a:rPr sz="1500" b="0" i="0">
+                <a:solidFill>
+                  <a:srgbClr val="0F172A"/>
+                </a:solidFill>
                 <a:latin typeface="Noto Sans Thai Looped"/>
               </a:rPr>
-              <a:t>• Grokking Simplicity — Eric Normand (Manning </a:t>
-            </a:r>
-            <a:r>
-              <a:rPr sz="1700" b="0" i="0">
+              <a:t> แยก Actions / Calculations / Data ให้ครบ</a:t>
+            </a:r>
+          </a:p>
+          <a:p>
+            <a:pPr algn="l">
+              <a:spcAft>
+                <a:spcPts val="800"/>
+              </a:spcAft>
+            </a:pPr>
+            <a:r>
+              <a:rPr sz="1500" b="0" i="0">
                 <a:solidFill>
                   <a:srgbClr val="0F172A"/>
                 </a:solidFill>
                 <a:latin typeface="Ubuntu"/>
               </a:rPr>
-              <a:t>2021</a:t>
-            </a:r>
-            <a:r>
-              <a:rPr sz="1700" b="0" i="0">
+              <a:t>2.</a:t>
+            </a:r>
+            <a:r>
+              <a:rPr sz="1500" b="0" i="0">
                 <a:solidFill>
                   <a:srgbClr val="0F172A"/>
                 </a:solidFill>
                 <a:latin typeface="Noto Sans Thai Looped"/>
               </a:rPr>
-              <a:t>) · โฟกัส ch.</a:t>
-            </a:r>
-            <a:r>
-              <a:rPr sz="1700" b="0" i="0">
+              <a:t> ดึง FindApplicableCoupons ออกมา — เขียน table-driven test ก่อน implementation</a:t>
+            </a:r>
+          </a:p>
+          <a:p>
+            <a:pPr algn="l">
+              <a:spcAft>
+                <a:spcPts val="800"/>
+              </a:spcAft>
+            </a:pPr>
+            <a:r>
+              <a:rPr sz="1500" b="0" i="0">
                 <a:solidFill>
                   <a:srgbClr val="0F172A"/>
                 </a:solidFill>
                 <a:latin typeface="Ubuntu"/>
               </a:rPr>
-              <a:t>3–5</a:t>
-            </a:r>
-            <a:r>
-              <a:rPr sz="1700" b="0" i="0">
+              <a:t>3.</a:t>
+            </a:r>
+            <a:r>
+              <a:rPr sz="1500" b="0" i="0">
                 <a:solidFill>
                   <a:srgbClr val="0F172A"/>
                 </a:solidFill>
                 <a:latin typeface="Noto Sans Thai Looped"/>
               </a:rPr>
-              <a:t> (ACD), ch.</a:t>
-            </a:r>
-            <a:r>
-              <a:rPr sz="1700" b="0" i="0">
+              <a:t> เหลือ SendCouponEmail เป็น action บาง ๆ</a:t>
+            </a:r>
+          </a:p>
+          <a:p>
+            <a:pPr algn="l">
+              <a:spcAft>
+                <a:spcPts val="800"/>
+              </a:spcAft>
+            </a:pPr>
+            <a:r>
+              <a:rPr sz="1500" b="0" i="0">
                 <a:solidFill>
                   <a:srgbClr val="0F172A"/>
                 </a:solidFill>
                 <a:latin typeface="Ubuntu"/>
               </a:rPr>
-              <a:t>6–7</a:t>
-            </a:r>
-            <a:r>
-              <a:rPr sz="1700" b="0" i="0">
+              <a:t>4.</a:t>
+            </a:r>
+            <a:r>
+              <a:rPr sz="1500" b="0" i="0">
                 <a:solidFill>
                   <a:srgbClr val="0F172A"/>
                 </a:solidFill>
                 <a:latin typeface="Noto Sans Thai Looped"/>
               </a:rPr>
-              <a:t> (immutability), ch.</a:t>
-            </a:r>
-            <a:r>
-              <a:rPr sz="1700" b="0" i="0">
-                <a:solidFill>
-                  <a:srgbClr val="0F172A"/>
-                </a:solidFill>
-                <a:latin typeface="Ubuntu"/>
-              </a:rPr>
-              <a:t>10–14</a:t>
-            </a:r>
-            <a:r>
-              <a:rPr sz="1700" b="0" i="0">
-                <a:solidFill>
-                  <a:srgbClr val="0F172A"/>
+              <a:t> ทำเสร็จค่อยเปิดดู solution/ ใน repo</a:t>
+            </a:r>
+          </a:p>
+          <a:p>
+            <a:pPr algn="l">
+              <a:spcAft>
+                <a:spcPts val="600"/>
+              </a:spcAft>
+            </a:pPr>
+            <a:r>
+              <a:rPr sz="1300" b="0" i="1">
+                <a:solidFill>
+                  <a:srgbClr val="64748B"/>
                 </a:solidFill>
                 <a:latin typeface="Noto Sans Thai Looped"/>
               </a:rPr>
-              <a:t> (first-class functions)</a:t>
-            </a:r>
-          </a:p>
-          <a:p>
-            <a:pPr algn="l">
-              <a:spcAft>
-                <a:spcPts val="800"/>
-              </a:spcAft>
-            </a:pPr>
-            <a:r>
-              <a:rPr sz="1700" b="0" i="0">
-                <a:solidFill>
-                  <a:srgbClr val="0F172A"/>
-                </a:solidFill>
-                <a:latin typeface="Noto Sans Thai Looped"/>
-              </a:rPr>
-              <a:t>• Functional Programming in Go — Dylan Meeus (Packt </a:t>
-            </a:r>
-            <a:r>
-              <a:rPr sz="1700" b="0" i="0">
-                <a:solidFill>
-                  <a:srgbClr val="0F172A"/>
-                </a:solidFill>
-                <a:latin typeface="Ubuntu"/>
-              </a:rPr>
-              <a:t>2023</a:t>
-            </a:r>
-            <a:r>
-              <a:rPr sz="1700" b="0" i="0">
-                <a:solidFill>
-                  <a:srgbClr val="0F172A"/>
-                </a:solidFill>
-                <a:latin typeface="Noto Sans Thai Looped"/>
-              </a:rPr>
-              <a:t>)</a:t>
-            </a:r>
-          </a:p>
-          <a:p>
-            <a:pPr algn="l">
-              <a:spcAft>
-                <a:spcPts val="800"/>
-              </a:spcAft>
-            </a:pPr>
-            <a:r>
-              <a:rPr sz="1700" b="0" i="0">
-                <a:solidFill>
-                  <a:srgbClr val="0F172A"/>
-                </a:solidFill>
-                <a:latin typeface="Noto Sans Thai Looped"/>
-              </a:rPr>
-              <a:t>• Go blog: Range Over Function Types (Go </a:t>
-            </a:r>
-            <a:r>
-              <a:rPr sz="1700" b="0" i="0">
-                <a:solidFill>
-                  <a:srgbClr val="0F172A"/>
-                </a:solidFill>
-                <a:latin typeface="Ubuntu"/>
-              </a:rPr>
-              <a:t>1.23</a:t>
-            </a:r>
-            <a:r>
-              <a:rPr sz="1700" b="0" i="0">
-                <a:solidFill>
-                  <a:srgbClr val="0F172A"/>
-                </a:solidFill>
-                <a:latin typeface="Noto Sans Thai Looped"/>
-              </a:rPr>
-              <a:t>) — go.dev/blog/range-functions</a:t>
-            </a:r>
-          </a:p>
-          <a:p>
-            <a:pPr algn="l">
-              <a:spcAft>
-                <a:spcPts val="800"/>
-              </a:spcAft>
-            </a:pPr>
-            <a:r>
-              <a:rPr sz="1700" b="0" i="0">
-                <a:solidFill>
-                  <a:srgbClr val="0F172A"/>
-                </a:solidFill>
-                <a:latin typeface="Noto Sans Thai Looped"/>
-              </a:rPr>
-              <a:t>• Codewalk: First-Class Functions in Go — go.dev/doc/codewalk/functions</a:t>
-            </a:r>
-          </a:p>
-          <a:p>
-            <a:pPr algn="l">
-              <a:spcAft>
-                <a:spcPts val="800"/>
-              </a:spcAft>
-            </a:pPr>
-            <a:r>
-              <a:rPr sz="1700" b="1" i="0">
-                <a:solidFill>
-                  <a:srgbClr val="0F172A"/>
-                </a:solidFill>
-                <a:latin typeface="Noto Sans Thai Looped"/>
-              </a:rPr>
-              <a:t>• โค้ดทั้งหมดในวันนี้ (พร้อมเทสต์): ~/src/go-fp — go test ./... ผ่านทุก package</a:t>
-            </a:r>
-          </a:p>
-        </p:txBody>
-      </p:sp>
-      <p:sp>
-        <p:nvSpPr>
-          <p:cNvPr id="5" name="TextBox 4"/>
-          <p:cNvSpPr txBox="1"/>
+              <a:t>กติกาโจทย์: เงินเป็นบาทเต็มไม่ติดลบ · coupon ไม่มีหมวด = ใช้ได้ทุกหมวด · รักษาลำดับเดิม</a:t>
+            </a:r>
+          </a:p>
+        </p:txBody>
+      </p:sp>
+      <p:sp>
+        <p:nvSpPr>
+          <p:cNvPr id="7" name="Rounded Rectangle 6"/>
+          <p:cNvSpPr/>
           <p:nvPr/>
         </p:nvSpPr>
         <p:spPr>
           <a:xfrm>
-            <a:off x="548640" y="5760720"/>
-            <a:ext cx="11064240" cy="640080"/>
+            <a:off x="548640" y="5989320"/>
+            <a:ext cx="11109960" cy="566928"/>
           </a:xfrm>
-          <a:prstGeom prst="rect">
+          <a:prstGeom prst="roundRect">
             <a:avLst/>
           </a:prstGeom>
-          <a:noFill/>
+          <a:solidFill>
+            <a:srgbClr val="CCFBF1"/>
+          </a:solidFill>
+          <a:ln>
+            <a:noFill/>
+          </a:ln>
+          <a:effectLst/>
         </p:spPr>
-        <p:txBody>
-          <a:bodyPr wrap="square">
-            <a:spAutoFit/>
-          </a:bodyPr>
-          <a:lstStyle/>
-          <a:p>
-            <a:pPr algn="l">
-              <a:spcAft>
-                <a:spcPts val="600"/>
-              </a:spcAft>
-            </a:pPr>
-            <a:r>
-              <a:rPr sz="2000" b="1" i="0">
-                <a:solidFill>
-                  <a:srgbClr val="0D9488"/>
+        <p:style>
+          <a:lnRef idx="1">
+            <a:schemeClr val="accent1"/>
+          </a:lnRef>
+          <a:fillRef idx="3">
+            <a:schemeClr val="accent1"/>
+          </a:fillRef>
+          <a:effectRef idx="2">
+            <a:schemeClr val="accent1"/>
+          </a:effectRef>
+          <a:fontRef idx="minor">
+            <a:schemeClr val="lt1"/>
+          </a:fontRef>
+        </p:style>
+        <p:txBody>
+          <a:bodyPr rtlCol="0" anchor="ctr" tIns="54864" bIns="36576" wrap="square"/>
+          <a:lstStyle/>
+          <a:p>
+            <a:pPr algn="l">
+              <a:spcAft>
+                <a:spcPts val="0"/>
+              </a:spcAft>
+            </a:pPr>
+            <a:r>
+              <a:rPr sz="1500" b="1" i="0">
+                <a:solidFill>
+                  <a:srgbClr val="0F766E"/>
                 </a:solidFill>
                 <a:latin typeface="Noto Sans Thai Looped"/>
               </a:rPr>
-              <a:t>ขอบคุณครับ 🙏 — คำถามได้ตลอด</a:t>
+              <a:t>จำไว้: เป้าหมาย: กติกาธุรกิจทั้งหมดอยู่ใน calculation ที่เทสต์ได้ โดยไม่ต้องแตะ I/O</a:t>
             </a:r>
           </a:p>
         </p:txBody>
@@ -9013,7 +8045,7 @@
 </p:sld>
 </file>
 
-<file path=ppt/slides/slide2.xml><?xml version="1.0" encoding="utf-8"?>
+<file path=ppt/slides/slide16.xml><?xml version="1.0" encoding="utf-8"?>
 <p:sld xmlns:a="http://schemas.openxmlformats.org/drawingml/2006/main" xmlns:p="http://schemas.openxmlformats.org/presentationml/2006/main" xmlns:r="http://schemas.openxmlformats.org/officeDocument/2006/relationships">
   <p:cSld>
     <p:spTree>
@@ -9057,41 +8089,7 @@
                 </a:solidFill>
                 <a:latin typeface="Noto Sans Thai Looped"/>
               </a:rPr>
-              <a:t>จบ </a:t>
-            </a:r>
-            <a:r>
-              <a:rPr sz="3000" b="1" i="0">
-                <a:solidFill>
-                  <a:srgbClr val="0F172A"/>
-                </a:solidFill>
-                <a:latin typeface="Ubuntu"/>
-              </a:rPr>
-              <a:t>2</a:t>
-            </a:r>
-            <a:r>
-              <a:rPr sz="3000" b="1" i="0">
-                <a:solidFill>
-                  <a:srgbClr val="0F172A"/>
-                </a:solidFill>
-                <a:latin typeface="Noto Sans Thai Looped"/>
-              </a:rPr>
-              <a:t> ชั่วโมงนี้ คุณจะได้</a:t>
-            </a:r>
-          </a:p>
-          <a:p>
-            <a:pPr algn="l">
-              <a:spcAft>
-                <a:spcPts val="600"/>
-              </a:spcAft>
-            </a:pPr>
-            <a:r>
-              <a:rPr sz="1500" b="0" i="0">
-                <a:solidFill>
-                  <a:srgbClr val="64748B"/>
-                </a:solidFill>
-                <a:latin typeface="Noto Sans Thai Looped"/>
-              </a:rPr>
-              <a:t>เรียงจาก 'มองเป็น' → 'เขียนเป็น' → 'ใช้เป็น'</a:t>
+              <a:t>อ่านต่อ</a:t>
             </a:r>
           </a:p>
         </p:txBody>
@@ -9147,6 +8145,390 @@
         </p:nvSpPr>
         <p:spPr>
           <a:xfrm>
+            <a:off x="548640" y="1645920"/>
+            <a:ext cx="11064240" cy="4937760"/>
+          </a:xfrm>
+          <a:prstGeom prst="rect">
+            <a:avLst/>
+          </a:prstGeom>
+          <a:noFill/>
+        </p:spPr>
+        <p:txBody>
+          <a:bodyPr wrap="square">
+            <a:spAutoFit/>
+          </a:bodyPr>
+          <a:lstStyle/>
+          <a:p>
+            <a:pPr algn="l">
+              <a:spcAft>
+                <a:spcPts val="800"/>
+              </a:spcAft>
+            </a:pPr>
+            <a:r>
+              <a:rPr sz="1700" b="0" i="0">
+                <a:solidFill>
+                  <a:srgbClr val="0F172A"/>
+                </a:solidFill>
+                <a:latin typeface="Noto Sans Thai Looped"/>
+              </a:rPr>
+              <a:t>• Grokking Simplicity — Eric Normand (Manning </a:t>
+            </a:r>
+            <a:r>
+              <a:rPr sz="1700" b="0" i="0">
+                <a:solidFill>
+                  <a:srgbClr val="0F172A"/>
+                </a:solidFill>
+                <a:latin typeface="Ubuntu"/>
+              </a:rPr>
+              <a:t>2021</a:t>
+            </a:r>
+            <a:r>
+              <a:rPr sz="1700" b="0" i="0">
+                <a:solidFill>
+                  <a:srgbClr val="0F172A"/>
+                </a:solidFill>
+                <a:latin typeface="Noto Sans Thai Looped"/>
+              </a:rPr>
+              <a:t>) · โฟกัส ch.</a:t>
+            </a:r>
+            <a:r>
+              <a:rPr sz="1700" b="0" i="0">
+                <a:solidFill>
+                  <a:srgbClr val="0F172A"/>
+                </a:solidFill>
+                <a:latin typeface="Ubuntu"/>
+              </a:rPr>
+              <a:t>3–5</a:t>
+            </a:r>
+            <a:r>
+              <a:rPr sz="1700" b="0" i="0">
+                <a:solidFill>
+                  <a:srgbClr val="0F172A"/>
+                </a:solidFill>
+                <a:latin typeface="Noto Sans Thai Looped"/>
+              </a:rPr>
+              <a:t> (ACD), ch.</a:t>
+            </a:r>
+            <a:r>
+              <a:rPr sz="1700" b="0" i="0">
+                <a:solidFill>
+                  <a:srgbClr val="0F172A"/>
+                </a:solidFill>
+                <a:latin typeface="Ubuntu"/>
+              </a:rPr>
+              <a:t>6–7</a:t>
+            </a:r>
+            <a:r>
+              <a:rPr sz="1700" b="0" i="0">
+                <a:solidFill>
+                  <a:srgbClr val="0F172A"/>
+                </a:solidFill>
+                <a:latin typeface="Noto Sans Thai Looped"/>
+              </a:rPr>
+              <a:t> (immutability), ch.</a:t>
+            </a:r>
+            <a:r>
+              <a:rPr sz="1700" b="0" i="0">
+                <a:solidFill>
+                  <a:srgbClr val="0F172A"/>
+                </a:solidFill>
+                <a:latin typeface="Ubuntu"/>
+              </a:rPr>
+              <a:t>10–14</a:t>
+            </a:r>
+            <a:r>
+              <a:rPr sz="1700" b="0" i="0">
+                <a:solidFill>
+                  <a:srgbClr val="0F172A"/>
+                </a:solidFill>
+                <a:latin typeface="Noto Sans Thai Looped"/>
+              </a:rPr>
+              <a:t> (first-class functions)</a:t>
+            </a:r>
+          </a:p>
+          <a:p>
+            <a:pPr algn="l">
+              <a:spcAft>
+                <a:spcPts val="800"/>
+              </a:spcAft>
+            </a:pPr>
+            <a:r>
+              <a:rPr sz="1700" b="0" i="0">
+                <a:solidFill>
+                  <a:srgbClr val="0F172A"/>
+                </a:solidFill>
+                <a:latin typeface="Noto Sans Thai Looped"/>
+              </a:rPr>
+              <a:t>• Functional Programming in Go — Dylan Meeus (Packt </a:t>
+            </a:r>
+            <a:r>
+              <a:rPr sz="1700" b="0" i="0">
+                <a:solidFill>
+                  <a:srgbClr val="0F172A"/>
+                </a:solidFill>
+                <a:latin typeface="Ubuntu"/>
+              </a:rPr>
+              <a:t>2023</a:t>
+            </a:r>
+            <a:r>
+              <a:rPr sz="1700" b="0" i="0">
+                <a:solidFill>
+                  <a:srgbClr val="0F172A"/>
+                </a:solidFill>
+                <a:latin typeface="Noto Sans Thai Looped"/>
+              </a:rPr>
+              <a:t>)</a:t>
+            </a:r>
+          </a:p>
+          <a:p>
+            <a:pPr algn="l">
+              <a:spcAft>
+                <a:spcPts val="800"/>
+              </a:spcAft>
+            </a:pPr>
+            <a:r>
+              <a:rPr sz="1700" b="0" i="0">
+                <a:solidFill>
+                  <a:srgbClr val="0F172A"/>
+                </a:solidFill>
+                <a:latin typeface="Noto Sans Thai Looped"/>
+              </a:rPr>
+              <a:t>• Go blog: Range Over Function Types (Go </a:t>
+            </a:r>
+            <a:r>
+              <a:rPr sz="1700" b="0" i="0">
+                <a:solidFill>
+                  <a:srgbClr val="0F172A"/>
+                </a:solidFill>
+                <a:latin typeface="Ubuntu"/>
+              </a:rPr>
+              <a:t>1.23</a:t>
+            </a:r>
+            <a:r>
+              <a:rPr sz="1700" b="0" i="0">
+                <a:solidFill>
+                  <a:srgbClr val="0F172A"/>
+                </a:solidFill>
+                <a:latin typeface="Noto Sans Thai Looped"/>
+              </a:rPr>
+              <a:t>) — go.dev/blog/range-functions</a:t>
+            </a:r>
+          </a:p>
+          <a:p>
+            <a:pPr algn="l">
+              <a:spcAft>
+                <a:spcPts val="800"/>
+              </a:spcAft>
+            </a:pPr>
+            <a:r>
+              <a:rPr sz="1700" b="0" i="0">
+                <a:solidFill>
+                  <a:srgbClr val="0F172A"/>
+                </a:solidFill>
+                <a:latin typeface="Noto Sans Thai Looped"/>
+              </a:rPr>
+              <a:t>• Codewalk: First-Class Functions in Go — go.dev/doc/codewalk/functions</a:t>
+            </a:r>
+          </a:p>
+          <a:p>
+            <a:pPr algn="l">
+              <a:spcAft>
+                <a:spcPts val="800"/>
+              </a:spcAft>
+            </a:pPr>
+            <a:r>
+              <a:rPr sz="1700" b="1" i="0">
+                <a:solidFill>
+                  <a:srgbClr val="0F172A"/>
+                </a:solidFill>
+                <a:latin typeface="Noto Sans Thai Looped"/>
+              </a:rPr>
+              <a:t>• โค้ดทั้งหมดในวันนี้ (พร้อมเทสต์): ~/src/go-fp — go test ./... ผ่านทุก package</a:t>
+            </a:r>
+          </a:p>
+        </p:txBody>
+      </p:sp>
+      <p:sp>
+        <p:nvSpPr>
+          <p:cNvPr id="5" name="TextBox 4"/>
+          <p:cNvSpPr txBox="1"/>
+          <p:nvPr/>
+        </p:nvSpPr>
+        <p:spPr>
+          <a:xfrm>
+            <a:off x="548640" y="5760720"/>
+            <a:ext cx="11064240" cy="640080"/>
+          </a:xfrm>
+          <a:prstGeom prst="rect">
+            <a:avLst/>
+          </a:prstGeom>
+          <a:noFill/>
+        </p:spPr>
+        <p:txBody>
+          <a:bodyPr wrap="square">
+            <a:spAutoFit/>
+          </a:bodyPr>
+          <a:lstStyle/>
+          <a:p>
+            <a:pPr algn="l">
+              <a:spcAft>
+                <a:spcPts val="600"/>
+              </a:spcAft>
+            </a:pPr>
+            <a:r>
+              <a:rPr sz="2000" b="1" i="0">
+                <a:solidFill>
+                  <a:srgbClr val="0D9488"/>
+                </a:solidFill>
+                <a:latin typeface="Noto Sans Thai Looped"/>
+              </a:rPr>
+              <a:t>ขอบคุณครับ 🙏 — คำถามได้ตลอด</a:t>
+            </a:r>
+          </a:p>
+        </p:txBody>
+      </p:sp>
+    </p:spTree>
+  </p:cSld>
+  <p:clrMapOvr>
+    <a:masterClrMapping/>
+  </p:clrMapOvr>
+</p:sld>
+</file>
+
+<file path=ppt/slides/slide2.xml><?xml version="1.0" encoding="utf-8"?>
+<p:sld xmlns:a="http://schemas.openxmlformats.org/drawingml/2006/main" xmlns:p="http://schemas.openxmlformats.org/presentationml/2006/main" xmlns:r="http://schemas.openxmlformats.org/officeDocument/2006/relationships">
+  <p:cSld>
+    <p:spTree>
+      <p:nvGrpSpPr>
+        <p:cNvPr id="1" name=""/>
+        <p:cNvGrpSpPr/>
+        <p:nvPr/>
+      </p:nvGrpSpPr>
+      <p:grpSpPr/>
+      <p:sp>
+        <p:nvSpPr>
+          <p:cNvPr id="2" name="TextBox 1"/>
+          <p:cNvSpPr txBox="1"/>
+          <p:nvPr/>
+        </p:nvSpPr>
+        <p:spPr>
+          <a:xfrm>
+            <a:off x="502920" y="292608"/>
+            <a:ext cx="11155680" cy="914400"/>
+          </a:xfrm>
+          <a:prstGeom prst="rect">
+            <a:avLst/>
+          </a:prstGeom>
+          <a:noFill/>
+        </p:spPr>
+        <p:txBody>
+          <a:bodyPr wrap="square">
+            <a:spAutoFit/>
+          </a:bodyPr>
+          <a:lstStyle/>
+          <a:p>
+            <a:pPr algn="l">
+              <a:spcAft>
+                <a:spcPts val="200"/>
+              </a:spcAft>
+            </a:pPr>
+            <a:r>
+              <a:rPr sz="3000" b="1" i="0">
+                <a:solidFill>
+                  <a:srgbClr val="0F172A"/>
+                </a:solidFill>
+                <a:latin typeface="Noto Sans Thai Looped"/>
+              </a:rPr>
+              <a:t>จบ </a:t>
+            </a:r>
+            <a:r>
+              <a:rPr sz="3000" b="1" i="0">
+                <a:solidFill>
+                  <a:srgbClr val="0F172A"/>
+                </a:solidFill>
+                <a:latin typeface="Ubuntu"/>
+              </a:rPr>
+              <a:t>2</a:t>
+            </a:r>
+            <a:r>
+              <a:rPr sz="3000" b="1" i="0">
+                <a:solidFill>
+                  <a:srgbClr val="0F172A"/>
+                </a:solidFill>
+                <a:latin typeface="Noto Sans Thai Looped"/>
+              </a:rPr>
+              <a:t> ชั่วโมงนี้ คุณจะได้</a:t>
+            </a:r>
+          </a:p>
+          <a:p>
+            <a:pPr algn="l">
+              <a:spcAft>
+                <a:spcPts val="600"/>
+              </a:spcAft>
+            </a:pPr>
+            <a:r>
+              <a:rPr sz="1500" b="0" i="0">
+                <a:solidFill>
+                  <a:srgbClr val="64748B"/>
+                </a:solidFill>
+                <a:latin typeface="Noto Sans Thai Looped"/>
+              </a:rPr>
+              <a:t>เรียงจาก 'มองเป็น' → 'เขียนเป็น' → 'ใช้เป็น'</a:t>
+            </a:r>
+          </a:p>
+        </p:txBody>
+      </p:sp>
+      <p:sp>
+        <p:nvSpPr>
+          <p:cNvPr id="3" name="Rectangle 2"/>
+          <p:cNvSpPr/>
+          <p:nvPr/>
+        </p:nvSpPr>
+        <p:spPr>
+          <a:xfrm>
+            <a:off x="502920" y="1207008"/>
+            <a:ext cx="11201400" cy="27940"/>
+          </a:xfrm>
+          <a:prstGeom prst="rect">
+            <a:avLst/>
+          </a:prstGeom>
+          <a:solidFill>
+            <a:srgbClr val="0D9488"/>
+          </a:solidFill>
+          <a:ln>
+            <a:noFill/>
+          </a:ln>
+        </p:spPr>
+        <p:style>
+          <a:lnRef idx="1">
+            <a:schemeClr val="accent1"/>
+          </a:lnRef>
+          <a:fillRef idx="3">
+            <a:schemeClr val="accent1"/>
+          </a:fillRef>
+          <a:effectRef idx="2">
+            <a:schemeClr val="accent1"/>
+          </a:effectRef>
+          <a:fontRef idx="minor">
+            <a:schemeClr val="lt1"/>
+          </a:fontRef>
+        </p:style>
+        <p:txBody>
+          <a:bodyPr rtlCol="0" anchor="ctr"/>
+          <a:lstStyle/>
+          <a:p>
+            <a:pPr algn="ctr"/>
+          </a:p>
+        </p:txBody>
+      </p:sp>
+      <p:sp>
+        <p:nvSpPr>
+          <p:cNvPr id="4" name="TextBox 3"/>
+          <p:cNvSpPr txBox="1"/>
+          <p:nvPr/>
+        </p:nvSpPr>
+        <p:spPr>
+          <a:xfrm>
             <a:off x="548640" y="1600200"/>
             <a:ext cx="11064240" cy="4937760"/>
           </a:xfrm>
@@ -9237,7 +8619,7 @@
                 </a:solidFill>
                 <a:latin typeface="Noto Sans Thai Looped"/>
               </a:rPr>
-              <a:t>• และได้ลงมือ refactor โค้ดจริงด้วยมือตัวเอง </a:t>
+              <a:t>• และมีการบ้าน </a:t>
             </a:r>
             <a:r>
               <a:rPr sz="1900" b="1" i="0">
@@ -9255,7 +8637,7 @@
                 </a:solidFill>
                 <a:latin typeface="Noto Sans Thai Looped"/>
               </a:rPr>
-              <a:t> ชิ้น ในชั่วโมงสุดท้าย</a:t>
+              <a:t> ชิ้น ให้ได้ลอง refactor ด้วยมือตัวเองต่อที่บ้าน</a:t>
             </a:r>
           </a:p>
         </p:txBody>

</xml_diff>